<commit_message>
fix(final): supply popup no fake zeros, 25km label fix, all docs aligned with actual UI, deck 7 modes + sustainability numbers, all audits addressed
</commit_message>
<xml_diff>
--- a/deck/AIS-42_PS-4B.pptx
+++ b/deck/AIS-42_PS-4B.pptx
@@ -3753,7 +3753,22 @@
                   <a:srgbClr val="22D3A7"/>
                 </a:solidFill>
               </a:rPr>
-              <a:t>Every percentage point of coverage = millions of people</a:t>
+              <a:t>14.75M people newly served = ~2.1 billion person-minutes of travel saved per year</a:t>
+            </a:r>
+          </a:p>
+          <a:p>
+            <a:pPr algn="l">
+              <a:spcAft>
+                <a:spcPts val="800"/>
+              </a:spcAft>
+            </a:pPr>
+            <a:r>
+              <a:rPr sz="1800" b="0">
+                <a:solidFill>
+                  <a:srgbClr val="8EA0C0"/>
+                </a:solidFill>
+              </a:rPr>
+              <a:t>Operated by block health offices under existing NHM Mobile Medical Unit guidelines</a:t>
             </a:r>
           </a:p>
         </p:txBody>

</xml_diff>